<commit_message>
Align CA2 presentation and demo plan with User Guide and current dashboard nav.
</commit_message>
<xml_diff>
--- a/deliverables/presentation/GreineQ_CA2_Presentation.pptx
+++ b/deliverables/presentation/GreineQ_CA2_Presentation.pptx
@@ -581,7 +581,7 @@
           <a:lstStyle/>
           <a:p>
             <a:r>
-              <a:t>Sources slide — do not present unless asked. Keep visible only if the panel requests provenance.</a:t>
+              <a:t>Sources slide — do not present unless asked. Keep visible only if the panel requests provenance. Point to User Guide Word doc and local localhost:8501 if asked how to operate the twin.</a:t>
             </a:r>
           </a:p>
         </p:txBody>
@@ -1001,7 +1001,7 @@
           <a:lstStyle/>
           <a:p>
             <a:r>
-              <a:t>The dashboard is the working-deployment mark: Digital Twin, Play vs Agent, curated results, and a live AEMO panel. Ethics is broader than bill harm: transparency of experimental tariff and partial live inputs; privacy and consent for future smart-meter data; fairness of access to batteries and tariffs; generalisability limited to one Ausgrid household and NSW1; safety via SOC and power limits, manual override, and greedy as fallback; and honesty that this is a software twin, not a physical battery. Play vs Agent is an interactive oversight demonstration — not a scientifically fair competition — because the human and privileged agent do not necessarily receive identical foresight.</a:t>
+              <a:t>The dashboard is the working-deployment mark. Top nav: Digital Twin, Price Monitor, Agent Play, Results, Overview. Twin auto-runs once, then use Run comparison after settings change; winner strip, charts, and timestep inspector. Price Monitor is live AEMO NSW1 with typical PV/load — separate from historical Twin. Ethics is broader than bill harm: transparency of experimental tariff and partial live inputs; privacy and consent for future smart-meter data; fairness of access to batteries and tariffs; generalisability limited to one Ausgrid household and NSW1; safety via SOC and power limits, manual override, and greedy as fallback; and honesty that this is a software twin, not a physical battery. Agent Play is an interactive oversight demonstration — not a scientifically fair competition — because the human always sees a realistic forecast while Privileged Q may use true four-hour direction. Operator steps are in deliverables/GreineQ_User_Guide.docx.</a:t>
             </a:r>
           </a:p>
         </p:txBody>
@@ -1141,7 +1141,7 @@
           <a:lstStyle/>
           <a:p>
             <a:r>
-              <a:t>Close in one line: we made arbitrage actionable, tested whether a four-hour three-bin direction feature helps tabular RL, found it does not beat greedy under this setup, and shipped a dashboard that makes that gap visible. Hand to Q&amp;A.</a:t>
+              <a:t>Close in one line: we made arbitrage actionable, tested whether a four-hour three-bin direction feature helps tabular RL, found it does not beat greedy under this setup, and shipped a dashboard that makes that gap visible. Demo path: Overview → Twin → Results → Agent Play (oversight) → optional Price Monitor. Hand to Q&amp;A.</a:t>
             </a:r>
           </a:p>
         </p:txBody>
@@ -4522,7 +4522,7 @@
               </a:spcAft>
             </a:pPr>
             <a:r>
-              <a:rPr sz="1400" b="0">
+              <a:rPr sz="1300" b="0">
                 <a:solidFill>
                   <a:srgbClr val="F8FAFC"/>
                 </a:solidFill>
@@ -4538,7 +4538,7 @@
               </a:spcAft>
             </a:pPr>
             <a:r>
-              <a:rPr sz="1400" b="0">
+              <a:rPr sz="1300" b="0">
                 <a:solidFill>
                   <a:srgbClr val="F8FAFC"/>
                 </a:solidFill>
@@ -4554,7 +4554,7 @@
               </a:spcAft>
             </a:pPr>
             <a:r>
-              <a:rPr sz="1400" b="0">
+              <a:rPr sz="1300" b="0">
                 <a:solidFill>
                   <a:srgbClr val="F8FAFC"/>
                 </a:solidFill>
@@ -4570,7 +4570,7 @@
               </a:spcAft>
             </a:pPr>
             <a:r>
-              <a:rPr sz="1400" b="0">
+              <a:rPr sz="1300" b="0">
                 <a:solidFill>
                   <a:srgbClr val="F8FAFC"/>
                 </a:solidFill>
@@ -4586,13 +4586,13 @@
               </a:spcAft>
             </a:pPr>
             <a:r>
-              <a:rPr sz="1400" b="0">
+              <a:rPr sz="1300" b="0">
                 <a:solidFill>
                   <a:srgbClr val="F8FAFC"/>
                 </a:solidFill>
                 <a:latin typeface="Calibri"/>
               </a:rPr>
-              <a:t>•  Local dashboard: http://localhost:8501  (prefer over production mirror)</a:t>
+              <a:t>•  User Guide: deliverables/GreineQ_User_Guide.docx (also .md) — Twin / Play / Results / Price Monitor</a:t>
             </a:r>
           </a:p>
           <a:p>
@@ -4602,7 +4602,23 @@
               </a:spcAft>
             </a:pPr>
             <a:r>
-              <a:rPr sz="1400" b="0">
+              <a:rPr sz="1300" b="0">
+                <a:solidFill>
+                  <a:srgbClr val="F8FAFC"/>
+                </a:solidFill>
+                <a:latin typeface="Calibri"/>
+              </a:rPr>
+              <a:t>•  Local dashboard: http://localhost:8501  (prefer over production mirror greineq-agent.sudocod.com)</a:t>
+            </a:r>
+          </a:p>
+          <a:p>
+            <a:pPr algn="l">
+              <a:spcAft>
+                <a:spcPts val="600"/>
+              </a:spcAft>
+            </a:pPr>
+            <a:r>
+              <a:rPr sz="1300" b="0">
                 <a:solidFill>
                   <a:srgbClr val="F8FAFC"/>
                 </a:solidFill>
@@ -7581,14 +7597,15 @@
           <a:p>
             <a:pPr algn="l"/>
             <a:r>
-              <a:rPr sz="1100" b="0">
+              <a:rPr sz="1000" b="0">
                 <a:solidFill>
                   <a:srgbClr val="94A3B8"/>
                 </a:solidFill>
                 <a:latin typeface="Calibri"/>
               </a:rPr>
-              <a:t>Twin · Play (oversight) · Results · Live AEMO
-Landing animation = heuristic preview, not trained Q</a:t>
+              <a:t>Nav: Twin · Price Monitor · Agent Play · Results · Overview
+Price Monitor ≠ Twin  ·  Landing animation = heuristic, not trained Q
+User Guide: deliverables/GreineQ_User_Guide.docx</a:t>
             </a:r>
           </a:p>
         </p:txBody>
@@ -7756,7 +7773,7 @@
                 </a:solidFill>
                 <a:latin typeface="Calibri"/>
               </a:rPr>
-              <a:t>•  Play mode = oversight demo, not a scientifically fair contest</a:t>
+              <a:t>•  Agent Play = oversight demo (realistic forecast vs true-direction privileged)</a:t>
             </a:r>
           </a:p>
         </p:txBody>
@@ -8497,7 +8514,7 @@
                 </a:solidFill>
                 <a:latin typeface="Calibri"/>
               </a:rPr>
-              <a:t>•  Digital Twin + Play vs Agent make the theory–deployed gap visible and challengeable</a:t>
+              <a:t>•  Digital Twin + Agent Play make the theory–deployed gap visible and challengeable</a:t>
             </a:r>
           </a:p>
         </p:txBody>
@@ -8524,13 +8541,13 @@
           <a:p>
             <a:pPr algn="l"/>
             <a:r>
-              <a:rPr sz="1500" b="0">
+              <a:rPr sz="1400" b="0">
                 <a:solidFill>
                   <a:srgbClr val="F59E1A"/>
                 </a:solidFill>
                 <a:latin typeface="Calibri"/>
               </a:rPr>
-              <a:t>Demo next → Digital Twin comparison · Experiment Results · Play vs Agent (oversight)</a:t>
+              <a:t>Demo next → Overview · Digital Twin · Results · Agent Play (oversight) · optional Price Monitor</a:t>
             </a:r>
           </a:p>
         </p:txBody>

</xml_diff>

<commit_message>
Add Streamlit-parity web Twin and harden dashboard deploy.
Ship FastAPI/web UI with landing hero, Twin experiment settings, Play charts, and Results learnings; fix Streamlit theme/nav and model mismatch guards.
</commit_message>
<xml_diff>
--- a/deliverables/presentation/GreineQ_CA2_Presentation.pptx
+++ b/deliverables/presentation/GreineQ_CA2_Presentation.pptx
@@ -511,7 +511,7 @@
           <a:lstStyle/>
           <a:p>
             <a:r>
-              <a:t>CA1 asked whether RL could beat simple solar self-consumption. CA2 asks whether forward-looking price information helps a tabular agent time grid arbitrage — and we tested that with a deployed digital twin. Nathan introduces the team and problem; Nadeesha owns the experiment narrative.</a:t>
+              <a:t>CA1 asked whether RL could beat simple solar self-consumption. CA2 asks whether forward-looking price information helps a tabular agent time grid arbitrage — and we tested that with a deployed digital twin. Emmanuel opens with the team and closes takeaways (non-technical). Nathan covers the problem/MDP and drives the Twin demo; Nadeesha owns the experiment narrative; Bahadir supports the recorded dashboard demo (backup clicks if needed).</a:t>
             </a:r>
           </a:p>
         </p:txBody>
@@ -581,7 +581,7 @@
           <a:lstStyle/>
           <a:p>
             <a:r>
-              <a:t>Sources slide — do not present unless asked. Keep visible only if the panel requests provenance. Point to User Guide Word doc and local localhost:8501 if asked how to operate the twin.</a:t>
+              <a:t>Sources slide — do not include in the recording unless the brief requires provenance on screen.</a:t>
             </a:r>
           </a:p>
         </p:txBody>
@@ -1071,7 +1071,7 @@
           <a:lstStyle/>
           <a:p>
             <a:r>
-              <a:t>Be precise, not generic. Limitations: three-bin direction without magnitude; experimental wholesale export; larger privileged table may under-train at 10k episodes; live feed is price-real and meter-partial. Next step targets magnitude or spread foresight — the bottleneck we identified — and keep greedy as a safety baseline until RL beats it on held-out days.</a:t>
+              <a:t>Be precise, not generic. Limitations: three-bin direction without magnitude; experimental wholesale export; larger privileged table may under-train at 10k episodes; live feed is price-real and meter-partial. Next step targets magnitude or spread foresight — the bottleneck we identified — and keep greedy as a safety baseline until RL beats it on held-out days. After this slide: switch to the dashboard for the recorded demo (~5 min), then return for Emmanuel’s slide 9 close.</a:t>
             </a:r>
           </a:p>
         </p:txBody>
@@ -1141,7 +1141,7 @@
           <a:lstStyle/>
           <a:p>
             <a:r>
-              <a:t>Close in one line: we made arbitrage actionable, tested whether a four-hour three-bin direction feature helps tabular RL, found it does not beat greedy under this setup, and shipped a dashboard that makes that gap visible. Demo path: Overview → Twin → Results → Agent Play (oversight) → optional Price Monitor. Hand to Q&amp;A.</a:t>
+              <a:t>Emmanuel closes the recording in one plain line: we made arbitrage actionable, tested whether a four-hour three-bin direction feature helps tabular RL, found it does not beat greedy under this setup, and shipped a dashboard that makes that gap visible. Stop cleanly — this is a 15-minute recording with no Q&amp;A.</a:t>
             </a:r>
           </a:p>
         </p:txBody>
@@ -4264,8 +4264,8 @@
         </p:nvSpPr>
         <p:spPr>
           <a:xfrm>
-            <a:off x="1371600" y="3108960"/>
-            <a:ext cx="9326880" cy="1280160"/>
+            <a:off x="1097280" y="2880360"/>
+            <a:ext cx="9875520" cy="1828800"/>
           </a:xfrm>
           <a:prstGeom prst="rect">
             <a:avLst/>
@@ -4278,14 +4278,16 @@
           <a:p>
             <a:pPr algn="ctr"/>
             <a:r>
-              <a:rPr sz="1500" b="0">
+              <a:rPr sz="1400" b="0">
                 <a:solidFill>
                   <a:srgbClr val="94A3B8"/>
                 </a:solidFill>
                 <a:latin typeface="Calibri"/>
               </a:rPr>
-              <a:t>Nathan Lucio  ·  [Student No.]  ·  Data &amp; MDP
-Nadeesha Jayasuriya  ·  [Student No.]  ·  RL experiment &amp; deployment
+              <a:t>Nathan Rocha  ·  20082900  ·  Data &amp; MDP
+Nadeesha Jayasuriya  ·  20093736  ·  RL experiment &amp; deployment
+Emmanuel Addoh  ·  10592825  ·  Opening &amp; closing
+Bahadir Demir  ·  20098301  ·  Dashboard &amp; demo support
 B9AI105 Reinforcement Learning  ·  Forecast-information experiment</a:t>
             </a:r>
           </a:p>
@@ -4299,8 +4301,8 @@
         </p:nvSpPr>
         <p:spPr>
           <a:xfrm>
-            <a:off x="1371600" y="4754880"/>
-            <a:ext cx="9326880" cy="548640"/>
+            <a:off x="1097280" y="4983480"/>
+            <a:ext cx="9875520" cy="640080"/>
           </a:xfrm>
           <a:prstGeom prst="rect">
             <a:avLst/>
@@ -4319,7 +4321,8 @@
                 </a:solidFill>
                 <a:latin typeface="Calibri"/>
               </a:rPr>
-              <a:t>Slide ownership: Nathan 1–3, 7  |  Nadeesha 4–6, 8–9  |  Demo: Nathan drives · Nadeesha narrates</a:t>
+              <a:t>Slides: Emmanuel 1 &amp; 9  ·  Nathan 2–3, 7  ·  Nadeesha 4–6, 8  ·  Bahadir demo backup
+15-min recording · no Q&amp;A  ·  Demo: Nathan drives · Nadeesha narrates · Bahadir backup</a:t>
             </a:r>
           </a:p>
         </p:txBody>
@@ -8547,7 +8550,7 @@
                 </a:solidFill>
                 <a:latin typeface="Calibri"/>
               </a:rPr>
-              <a:t>Demo next → Overview · Digital Twin · Results · Agent Play (oversight) · optional Price Monitor</a:t>
+              <a:t>15-minute recording · no Q&amp;A  ·  End after this close</a:t>
             </a:r>
           </a:p>
         </p:txBody>

</xml_diff>